<commit_message>
Updated abstract use cases
</commit_message>
<xml_diff>
--- a/Slides/Pose Detection/Pose_Detection_01.pptx
+++ b/Slides/Pose Detection/Pose_Detection_01.pptx
@@ -5,7 +5,7 @@
     <p:sldMasterId id="2147483659" r:id="rId1"/>
   </p:sldMasterIdLst>
   <p:notesMasterIdLst>
-    <p:notesMasterId r:id="rId20"/>
+    <p:notesMasterId r:id="rId22"/>
   </p:notesMasterIdLst>
   <p:sldIdLst>
     <p:sldId id="256" r:id="rId2"/>
@@ -26,6 +26,8 @@
     <p:sldId id="291" r:id="rId17"/>
     <p:sldId id="292" r:id="rId18"/>
     <p:sldId id="273" r:id="rId19"/>
+    <p:sldId id="294" r:id="rId20"/>
+    <p:sldId id="293" r:id="rId21"/>
   </p:sldIdLst>
   <p:sldSz cx="9144000" cy="5143500" type="screen16x9"/>
   <p:notesSz cx="6858000" cy="9144000"/>
@@ -1952,6 +1954,133 @@
 </p:notes>
 </file>
 
+<file path=ppt/notesSlides/notesSlide19.xml><?xml version="1.0" encoding="utf-8"?>
+<p:notes xmlns:a="http://schemas.openxmlformats.org/drawingml/2006/main" xmlns:r="http://schemas.openxmlformats.org/officeDocument/2006/relationships" xmlns:p="http://schemas.openxmlformats.org/presentationml/2006/main" showMasterSp="0" showMasterPhAnim="0">
+  <p:cSld>
+    <p:spTree>
+      <p:nvGrpSpPr>
+        <p:cNvPr id="1" name="Shape 183">
+          <a:extLst>
+            <a:ext uri="{FF2B5EF4-FFF2-40B4-BE49-F238E27FC236}">
+              <a16:creationId xmlns:a16="http://schemas.microsoft.com/office/drawing/2014/main" id="{CD19ADDE-AFB7-D542-4CCB-CF45448EBBED}"/>
+            </a:ext>
+          </a:extLst>
+        </p:cNvPr>
+        <p:cNvGrpSpPr/>
+        <p:nvPr/>
+      </p:nvGrpSpPr>
+      <p:grpSpPr>
+        <a:xfrm>
+          <a:off x="0" y="0"/>
+          <a:ext cx="0" cy="0"/>
+          <a:chOff x="0" y="0"/>
+          <a:chExt cx="0" cy="0"/>
+        </a:xfrm>
+      </p:grpSpPr>
+      <p:sp>
+        <p:nvSpPr>
+          <p:cNvPr id="184" name="Google Shape;184;g378ebe71614_0_7:notes">
+            <a:extLst>
+              <a:ext uri="{FF2B5EF4-FFF2-40B4-BE49-F238E27FC236}">
+                <a16:creationId xmlns:a16="http://schemas.microsoft.com/office/drawing/2014/main" id="{18BFF4BB-B269-5983-51A0-748366326243}"/>
+              </a:ext>
+            </a:extLst>
+          </p:cNvPr>
+          <p:cNvSpPr>
+            <a:spLocks noGrp="1" noRot="1" noChangeAspect="1"/>
+          </p:cNvSpPr>
+          <p:nvPr>
+            <p:ph type="sldImg" idx="2"/>
+          </p:nvPr>
+        </p:nvSpPr>
+        <p:spPr>
+          <a:xfrm>
+            <a:off x="381000" y="685800"/>
+            <a:ext cx="6096000" cy="3429000"/>
+          </a:xfrm>
+          <a:custGeom>
+            <a:avLst/>
+            <a:gdLst/>
+            <a:ahLst/>
+            <a:cxnLst/>
+            <a:rect l="l" t="t" r="r" b="b"/>
+            <a:pathLst>
+              <a:path w="120000" h="120000" extrusionOk="0">
+                <a:moveTo>
+                  <a:pt x="0" y="0"/>
+                </a:moveTo>
+                <a:lnTo>
+                  <a:pt x="120000" y="0"/>
+                </a:lnTo>
+                <a:lnTo>
+                  <a:pt x="120000" y="120000"/>
+                </a:lnTo>
+                <a:lnTo>
+                  <a:pt x="0" y="120000"/>
+                </a:lnTo>
+                <a:close/>
+              </a:path>
+            </a:pathLst>
+          </a:custGeom>
+        </p:spPr>
+      </p:sp>
+      <p:sp>
+        <p:nvSpPr>
+          <p:cNvPr id="185" name="Google Shape;185;g378ebe71614_0_7:notes">
+            <a:extLst>
+              <a:ext uri="{FF2B5EF4-FFF2-40B4-BE49-F238E27FC236}">
+                <a16:creationId xmlns:a16="http://schemas.microsoft.com/office/drawing/2014/main" id="{E6FBEBA8-6C4A-DCCA-CC46-DEF674CC1C0F}"/>
+              </a:ext>
+            </a:extLst>
+          </p:cNvPr>
+          <p:cNvSpPr txBox="1">
+            <a:spLocks noGrp="1"/>
+          </p:cNvSpPr>
+          <p:nvPr>
+            <p:ph type="body" idx="1"/>
+          </p:nvPr>
+        </p:nvSpPr>
+        <p:spPr>
+          <a:xfrm>
+            <a:off x="685800" y="4343400"/>
+            <a:ext cx="5486400" cy="4114800"/>
+          </a:xfrm>
+          <a:prstGeom prst="rect">
+            <a:avLst/>
+          </a:prstGeom>
+        </p:spPr>
+        <p:txBody>
+          <a:bodyPr spcFirstLastPara="1" wrap="square" lIns="91425" tIns="91425" rIns="91425" bIns="91425" anchor="t" anchorCtr="0">
+            <a:noAutofit/>
+          </a:bodyPr>
+          <a:lstStyle/>
+          <a:p>
+            <a:pPr marL="0" lvl="0" indent="0" algn="l" rtl="0">
+              <a:spcBef>
+                <a:spcPts val="0"/>
+              </a:spcBef>
+              <a:spcAft>
+                <a:spcPts val="0"/>
+              </a:spcAft>
+              <a:buNone/>
+            </a:pPr>
+            <a:endParaRPr/>
+          </a:p>
+        </p:txBody>
+      </p:sp>
+    </p:spTree>
+    <p:extLst>
+      <p:ext uri="{BB962C8B-B14F-4D97-AF65-F5344CB8AC3E}">
+        <p14:creationId xmlns:p14="http://schemas.microsoft.com/office/powerpoint/2010/main" val="147871711"/>
+      </p:ext>
+    </p:extLst>
+  </p:cSld>
+  <p:clrMapOvr>
+    <a:masterClrMapping/>
+  </p:clrMapOvr>
+</p:notes>
+</file>
+
 <file path=ppt/notesSlides/notesSlide2.xml><?xml version="1.0" encoding="utf-8"?>
 <p:notes xmlns:a="http://schemas.openxmlformats.org/drawingml/2006/main" xmlns:r="http://schemas.openxmlformats.org/officeDocument/2006/relationships" xmlns:p="http://schemas.openxmlformats.org/presentationml/2006/main" showMasterSp="0" showMasterPhAnim="0">
   <p:cSld>
@@ -2049,6 +2178,133 @@
         </p:txBody>
       </p:sp>
     </p:spTree>
+  </p:cSld>
+  <p:clrMapOvr>
+    <a:masterClrMapping/>
+  </p:clrMapOvr>
+</p:notes>
+</file>
+
+<file path=ppt/notesSlides/notesSlide20.xml><?xml version="1.0" encoding="utf-8"?>
+<p:notes xmlns:a="http://schemas.openxmlformats.org/drawingml/2006/main" xmlns:r="http://schemas.openxmlformats.org/officeDocument/2006/relationships" xmlns:p="http://schemas.openxmlformats.org/presentationml/2006/main" showMasterSp="0" showMasterPhAnim="0">
+  <p:cSld>
+    <p:spTree>
+      <p:nvGrpSpPr>
+        <p:cNvPr id="1" name="Shape 183">
+          <a:extLst>
+            <a:ext uri="{FF2B5EF4-FFF2-40B4-BE49-F238E27FC236}">
+              <a16:creationId xmlns:a16="http://schemas.microsoft.com/office/drawing/2014/main" id="{72FC9FB4-A7E7-64B7-BA86-D3A29AE7B3B4}"/>
+            </a:ext>
+          </a:extLst>
+        </p:cNvPr>
+        <p:cNvGrpSpPr/>
+        <p:nvPr/>
+      </p:nvGrpSpPr>
+      <p:grpSpPr>
+        <a:xfrm>
+          <a:off x="0" y="0"/>
+          <a:ext cx="0" cy="0"/>
+          <a:chOff x="0" y="0"/>
+          <a:chExt cx="0" cy="0"/>
+        </a:xfrm>
+      </p:grpSpPr>
+      <p:sp>
+        <p:nvSpPr>
+          <p:cNvPr id="184" name="Google Shape;184;g378ebe71614_0_7:notes">
+            <a:extLst>
+              <a:ext uri="{FF2B5EF4-FFF2-40B4-BE49-F238E27FC236}">
+                <a16:creationId xmlns:a16="http://schemas.microsoft.com/office/drawing/2014/main" id="{FCD3499C-B991-1806-B70C-52421DB20EDB}"/>
+              </a:ext>
+            </a:extLst>
+          </p:cNvPr>
+          <p:cNvSpPr>
+            <a:spLocks noGrp="1" noRot="1" noChangeAspect="1"/>
+          </p:cNvSpPr>
+          <p:nvPr>
+            <p:ph type="sldImg" idx="2"/>
+          </p:nvPr>
+        </p:nvSpPr>
+        <p:spPr>
+          <a:xfrm>
+            <a:off x="381000" y="685800"/>
+            <a:ext cx="6096000" cy="3429000"/>
+          </a:xfrm>
+          <a:custGeom>
+            <a:avLst/>
+            <a:gdLst/>
+            <a:ahLst/>
+            <a:cxnLst/>
+            <a:rect l="l" t="t" r="r" b="b"/>
+            <a:pathLst>
+              <a:path w="120000" h="120000" extrusionOk="0">
+                <a:moveTo>
+                  <a:pt x="0" y="0"/>
+                </a:moveTo>
+                <a:lnTo>
+                  <a:pt x="120000" y="0"/>
+                </a:lnTo>
+                <a:lnTo>
+                  <a:pt x="120000" y="120000"/>
+                </a:lnTo>
+                <a:lnTo>
+                  <a:pt x="0" y="120000"/>
+                </a:lnTo>
+                <a:close/>
+              </a:path>
+            </a:pathLst>
+          </a:custGeom>
+        </p:spPr>
+      </p:sp>
+      <p:sp>
+        <p:nvSpPr>
+          <p:cNvPr id="185" name="Google Shape;185;g378ebe71614_0_7:notes">
+            <a:extLst>
+              <a:ext uri="{FF2B5EF4-FFF2-40B4-BE49-F238E27FC236}">
+                <a16:creationId xmlns:a16="http://schemas.microsoft.com/office/drawing/2014/main" id="{CC90C4BD-AD93-F323-86BC-8B4C9273A193}"/>
+              </a:ext>
+            </a:extLst>
+          </p:cNvPr>
+          <p:cNvSpPr txBox="1">
+            <a:spLocks noGrp="1"/>
+          </p:cNvSpPr>
+          <p:nvPr>
+            <p:ph type="body" idx="1"/>
+          </p:nvPr>
+        </p:nvSpPr>
+        <p:spPr>
+          <a:xfrm>
+            <a:off x="685800" y="4343400"/>
+            <a:ext cx="5486400" cy="4114800"/>
+          </a:xfrm>
+          <a:prstGeom prst="rect">
+            <a:avLst/>
+          </a:prstGeom>
+        </p:spPr>
+        <p:txBody>
+          <a:bodyPr spcFirstLastPara="1" wrap="square" lIns="91425" tIns="91425" rIns="91425" bIns="91425" anchor="t" anchorCtr="0">
+            <a:noAutofit/>
+          </a:bodyPr>
+          <a:lstStyle/>
+          <a:p>
+            <a:pPr marL="0" lvl="0" indent="0" algn="l" rtl="0">
+              <a:spcBef>
+                <a:spcPts val="0"/>
+              </a:spcBef>
+              <a:spcAft>
+                <a:spcPts val="0"/>
+              </a:spcAft>
+              <a:buNone/>
+            </a:pPr>
+            <a:endParaRPr/>
+          </a:p>
+        </p:txBody>
+      </p:sp>
+    </p:spTree>
+    <p:extLst>
+      <p:ext uri="{BB962C8B-B14F-4D97-AF65-F5344CB8AC3E}">
+        <p14:creationId xmlns:p14="http://schemas.microsoft.com/office/powerpoint/2010/main" val="29677098"/>
+      </p:ext>
+    </p:extLst>
   </p:cSld>
   <p:clrMapOvr>
     <a:masterClrMapping/>
@@ -7968,7 +8224,7 @@
                 <a:cs typeface="Calibri"/>
                 <a:sym typeface="Calibri"/>
               </a:rPr>
-              <a:t>Formalisms for the three Pose types and their decorations.</a:t>
+              <a:t>Finding objects and their poses.</a:t>
             </a:r>
             <a:endParaRPr sz="2060" dirty="0">
               <a:latin typeface="Calibri"/>
@@ -9050,7 +9306,7 @@
           <a:bodyPr/>
           <a:lstStyle/>
           <a:p>
-            <a:endParaRPr lang="en-US"/>
+            <a:endParaRPr lang="en-US" dirty="0"/>
           </a:p>
         </p:txBody>
       </p:sp>
@@ -9119,15 +9375,15 @@
               <a:buNone/>
             </a:pPr>
             <a:r>
-              <a:rPr lang="en">
+              <a:rPr lang="en" dirty="0">
                 <a:latin typeface="Calibri"/>
                 <a:ea typeface="Calibri"/>
                 <a:cs typeface="Calibri"/>
                 <a:sym typeface="Calibri"/>
               </a:rPr>
-              <a:t>References: Overview</a:t>
-            </a:r>
-            <a:endParaRPr>
+              <a:t>References 1-6: Detection</a:t>
+            </a:r>
+            <a:endParaRPr dirty="0">
               <a:latin typeface="Calibri"/>
               <a:ea typeface="Calibri"/>
               <a:cs typeface="Calibri"/>
@@ -9136,7 +9392,1259 @@
           </a:p>
         </p:txBody>
       </p:sp>
+      <p:sp>
+        <p:nvSpPr>
+          <p:cNvPr id="7" name="TextBox 6">
+            <a:extLst>
+              <a:ext uri="{FF2B5EF4-FFF2-40B4-BE49-F238E27FC236}">
+                <a16:creationId xmlns:a16="http://schemas.microsoft.com/office/drawing/2014/main" id="{949B262C-4311-0BFF-302C-70ED2CEFA3A7}"/>
+              </a:ext>
+            </a:extLst>
+          </p:cNvPr>
+          <p:cNvSpPr txBox="1"/>
+          <p:nvPr/>
+        </p:nvSpPr>
+        <p:spPr>
+          <a:xfrm>
+            <a:off x="405684" y="-13887710"/>
+            <a:ext cx="6336406" cy="24868346"/>
+          </a:xfrm>
+          <a:prstGeom prst="rect">
+            <a:avLst/>
+          </a:prstGeom>
+          <a:noFill/>
+        </p:spPr>
+        <p:txBody>
+          <a:bodyPr wrap="square">
+            <a:spAutoFit/>
+          </a:bodyPr>
+          <a:lstStyle/>
+          <a:p>
+            <a:pPr>
+              <a:buNone/>
+            </a:pPr>
+            <a:r>
+              <a:rPr lang="en-US" b="1" dirty="0"/>
+              <a:t>Key References on Visual Velocimetry</a:t>
+            </a:r>
+          </a:p>
+          <a:p>
+            <a:pPr>
+              <a:buFont typeface="+mj-lt"/>
+              <a:buAutoNum type="arabicPeriod"/>
+            </a:pPr>
+            <a:r>
+              <a:rPr lang="en-US" dirty="0"/>
+              <a:t>Pimienta, Juan, &amp; Aider, Jean-Luc. (2024). </a:t>
+            </a:r>
+            <a:r>
+              <a:rPr lang="en-US" i="1" dirty="0"/>
+              <a:t>Towards High Resolution Real-Time Optical Flow Particle Image Velocimetry</a:t>
+            </a:r>
+            <a:r>
+              <a:rPr lang="en-US" dirty="0"/>
+              <a:t>. arXiv:2407.03057. </a:t>
+            </a:r>
+            <a:r>
+              <a:rPr lang="en-US" dirty="0" err="1">
+                <a:hlinkClick r:id="rId3"/>
+              </a:rPr>
+              <a:t>arXiv</a:t>
+            </a:r>
+            <a:br>
+              <a:rPr lang="en-US" dirty="0"/>
+            </a:br>
+            <a:r>
+              <a:rPr lang="en-US" dirty="0"/>
+              <a:t>— Demonstrates dense (one vector per pixel) velocity field estimation in real time using optical flow in place of classical PIV. </a:t>
+            </a:r>
+            <a:r>
+              <a:rPr lang="en-US" dirty="0" err="1">
+                <a:hlinkClick r:id="rId3"/>
+              </a:rPr>
+              <a:t>arXiv</a:t>
+            </a:r>
+            <a:endParaRPr lang="en-US" dirty="0"/>
+          </a:p>
+          <a:p>
+            <a:pPr>
+              <a:buFont typeface="+mj-lt"/>
+              <a:buAutoNum type="arabicPeriod"/>
+            </a:pPr>
+            <a:r>
+              <a:rPr lang="en-US" dirty="0"/>
+              <a:t>Tran, Phu N., Ray, Sattvic, Lemma, Linnea, Li, </a:t>
+            </a:r>
+            <a:r>
+              <a:rPr lang="en-US" dirty="0" err="1"/>
+              <a:t>Yunrui</a:t>
+            </a:r>
+            <a:r>
+              <a:rPr lang="en-US" dirty="0"/>
+              <a:t>, Sweeney, Reef, Baskaran, Aparna, Dogic, Zvonimir, &amp; Hagan, Michael F. (2024). </a:t>
+            </a:r>
+            <a:r>
+              <a:rPr lang="en-US" i="1" dirty="0"/>
+              <a:t>Deep learning optical flow for measuring velocity fields from experimental data</a:t>
+            </a:r>
+            <a:r>
+              <a:rPr lang="en-US" dirty="0"/>
+              <a:t>. Soft Matter, 20, 7246-7257. </a:t>
+            </a:r>
+            <a:r>
+              <a:rPr lang="en-US" dirty="0">
+                <a:hlinkClick r:id="rId4"/>
+              </a:rPr>
+              <a:t>pubs.rsc.org</a:t>
+            </a:r>
+            <a:br>
+              <a:rPr lang="en-US" dirty="0"/>
+            </a:br>
+            <a:r>
+              <a:rPr lang="en-US" dirty="0"/>
+              <a:t>— Compares deep-learning optical flow (DLOF) with PIV in biophysical systems and shows advantages of DLOF for dense labeling and higher resolution. </a:t>
+            </a:r>
+            <a:r>
+              <a:rPr lang="en-US" dirty="0">
+                <a:hlinkClick r:id="rId4"/>
+              </a:rPr>
+              <a:t>pubs.rsc.org</a:t>
+            </a:r>
+            <a:endParaRPr lang="en-US" dirty="0"/>
+          </a:p>
+          <a:p>
+            <a:pPr>
+              <a:buFont typeface="+mj-lt"/>
+              <a:buAutoNum type="arabicPeriod"/>
+            </a:pPr>
+            <a:r>
+              <a:rPr lang="en-US" dirty="0" err="1"/>
+              <a:t>Stulov</a:t>
+            </a:r>
+            <a:r>
+              <a:rPr lang="en-US" dirty="0"/>
+              <a:t>, Nikolay, &amp; </a:t>
+            </a:r>
+            <a:r>
+              <a:rPr lang="en-US" dirty="0" err="1"/>
+              <a:t>Chertkov</a:t>
+            </a:r>
+            <a:r>
+              <a:rPr lang="en-US" dirty="0"/>
+              <a:t>, Michael. (2021). </a:t>
+            </a:r>
+            <a:r>
+              <a:rPr lang="en-US" i="1" dirty="0"/>
+              <a:t>Neural Particle Image Velocimetry</a:t>
+            </a:r>
+            <a:r>
+              <a:rPr lang="en-US" dirty="0"/>
+              <a:t>. arXiv:2101.11950. </a:t>
+            </a:r>
+            <a:r>
+              <a:rPr lang="en-US" dirty="0" err="1">
+                <a:hlinkClick r:id="rId5"/>
+              </a:rPr>
+              <a:t>arXiv</a:t>
+            </a:r>
+            <a:br>
+              <a:rPr lang="en-US" dirty="0"/>
+            </a:br>
+            <a:r>
+              <a:rPr lang="en-US" dirty="0"/>
+              <a:t>— Proposes a convolutional neural network approach (Volumetric Correspondence Network) for estimating fine‐grained velocity fields from PIV imagery, designed to be faster and accurate. </a:t>
+            </a:r>
+            <a:r>
+              <a:rPr lang="en-US" dirty="0" err="1">
+                <a:hlinkClick r:id="rId5"/>
+              </a:rPr>
+              <a:t>arXiv</a:t>
+            </a:r>
+            <a:endParaRPr lang="en-US" dirty="0"/>
+          </a:p>
+          <a:p>
+            <a:pPr>
+              <a:buFont typeface="+mj-lt"/>
+              <a:buAutoNum type="arabicPeriod"/>
+            </a:pPr>
+            <a:r>
+              <a:rPr lang="en-US" dirty="0"/>
+              <a:t>Gautier, N., &amp; Aider, J-L. (2013). </a:t>
+            </a:r>
+            <a:r>
+              <a:rPr lang="en-US" i="1" dirty="0"/>
+              <a:t>Real-time planar flow velocity measurements using an optical flow algorithm implemented on GPU</a:t>
+            </a:r>
+            <a:r>
+              <a:rPr lang="en-US" dirty="0"/>
+              <a:t>. arXiv:1306.2461. </a:t>
+            </a:r>
+            <a:r>
+              <a:rPr lang="en-US" dirty="0" err="1">
+                <a:hlinkClick r:id="rId6"/>
+              </a:rPr>
+              <a:t>arXiv</a:t>
+            </a:r>
+            <a:br>
+              <a:rPr lang="en-US" dirty="0"/>
+            </a:br>
+            <a:r>
+              <a:rPr lang="en-US" dirty="0"/>
+              <a:t>— Real-time optical flow on GPU for experimental flows; compares against offline PIV, showing good accuracy in recovering flow features such as recirculation bubbles. </a:t>
+            </a:r>
+            <a:r>
+              <a:rPr lang="en-US" dirty="0" err="1">
+                <a:hlinkClick r:id="rId6"/>
+              </a:rPr>
+              <a:t>arXiv</a:t>
+            </a:r>
+            <a:endParaRPr lang="en-US" dirty="0"/>
+          </a:p>
+          <a:p>
+            <a:pPr>
+              <a:buFont typeface="+mj-lt"/>
+              <a:buAutoNum type="arabicPeriod"/>
+            </a:pPr>
+            <a:r>
+              <a:rPr lang="en-US" dirty="0"/>
+              <a:t>Willert, Christian, &amp; Klinner, Joachim. (2022). </a:t>
+            </a:r>
+            <a:r>
+              <a:rPr lang="en-US" i="1" dirty="0"/>
+              <a:t>Event-based Imaging Velocimetry — An Assessment of Event-based Cameras for the Measurement of Fluid Flows</a:t>
+            </a:r>
+            <a:r>
+              <a:rPr lang="en-US" dirty="0"/>
+              <a:t>. arXiv:2202.11178. </a:t>
+            </a:r>
+            <a:r>
+              <a:rPr lang="en-US" dirty="0" err="1">
+                <a:hlinkClick r:id="rId7"/>
+              </a:rPr>
+              <a:t>arXiv</a:t>
+            </a:r>
+            <a:br>
+              <a:rPr lang="en-US" dirty="0"/>
+            </a:br>
+            <a:r>
+              <a:rPr lang="en-US" dirty="0"/>
+              <a:t>— Looks at using event-based cameras (which detect changes rather than full frames) for velocimetry; proposes algorithms to derive velocity from the event streams. </a:t>
+            </a:r>
+            <a:r>
+              <a:rPr lang="en-US" dirty="0" err="1">
+                <a:hlinkClick r:id="rId7"/>
+              </a:rPr>
+              <a:t>arXiv</a:t>
+            </a:r>
+            <a:endParaRPr lang="en-US" dirty="0"/>
+          </a:p>
+          <a:p>
+            <a:pPr>
+              <a:buFont typeface="+mj-lt"/>
+              <a:buAutoNum type="arabicPeriod"/>
+            </a:pPr>
+            <a:r>
+              <a:rPr lang="en-US" dirty="0"/>
+              <a:t>Masker, Andrew I., Ke Zhou, Joseph P. Molnar, &amp; Samuel J. Grauer. (2024). </a:t>
+            </a:r>
+            <a:r>
+              <a:rPr lang="en-US" i="1" dirty="0"/>
+              <a:t>Neural optical flow for planar and stereo PIV</a:t>
+            </a:r>
+            <a:r>
+              <a:rPr lang="en-US" dirty="0"/>
+              <a:t>. arXiv:2411.02373. </a:t>
+            </a:r>
+            <a:r>
+              <a:rPr lang="en-US" dirty="0" err="1">
+                <a:hlinkClick r:id="rId8"/>
+              </a:rPr>
+              <a:t>arXiv</a:t>
+            </a:r>
+            <a:br>
+              <a:rPr lang="en-US" dirty="0"/>
+            </a:br>
+            <a:r>
+              <a:rPr lang="en-US" dirty="0"/>
+              <a:t>— Introduces a neural‐implicit representation of the velocity field, with continuous parameterization, and constraints (like continuity or physics priors) to improve flow and possibly pressure inference. </a:t>
+            </a:r>
+            <a:r>
+              <a:rPr lang="en-US" dirty="0" err="1">
+                <a:hlinkClick r:id="rId8"/>
+              </a:rPr>
+              <a:t>arXiv</a:t>
+            </a:r>
+            <a:endParaRPr lang="en-US" dirty="0"/>
+          </a:p>
+          <a:p>
+            <a:pPr>
+              <a:buFont typeface="+mj-lt"/>
+              <a:buAutoNum type="arabicPeriod"/>
+            </a:pPr>
+            <a:r>
+              <a:rPr lang="en-US" i="1" dirty="0"/>
+              <a:t>Particle image velocimetry - Classical operating rules from today’s PIV</a:t>
+            </a:r>
+            <a:r>
+              <a:rPr lang="en-US" dirty="0"/>
+              <a:t>. (2019). </a:t>
+            </a:r>
+            <a:r>
+              <a:rPr lang="en-US" dirty="0">
+                <a:hlinkClick r:id="rId9"/>
+              </a:rPr>
+              <a:t>ScienceDirect</a:t>
+            </a:r>
+            <a:br>
+              <a:rPr lang="en-US" dirty="0"/>
+            </a:br>
+            <a:r>
+              <a:rPr lang="en-US" dirty="0"/>
+              <a:t>— A broad review of PIV techniques, historical and recent developments. Useful for baseline and context. </a:t>
+            </a:r>
+            <a:r>
+              <a:rPr lang="en-US" dirty="0">
+                <a:hlinkClick r:id="rId9"/>
+              </a:rPr>
+              <a:t>ScienceDirect</a:t>
+            </a:r>
+            <a:endParaRPr lang="en-US" dirty="0"/>
+          </a:p>
+          <a:p>
+            <a:pPr>
+              <a:buFont typeface="+mj-lt"/>
+              <a:buAutoNum type="arabicPeriod"/>
+            </a:pPr>
+            <a:r>
+              <a:rPr lang="en-US" i="1" dirty="0"/>
+              <a:t>Estimating optical flow: A comprehensive review of the state of the art</a:t>
+            </a:r>
+            <a:r>
+              <a:rPr lang="en-US" dirty="0"/>
+              <a:t>. (2024). </a:t>
+            </a:r>
+            <a:r>
+              <a:rPr lang="en-US" dirty="0">
+                <a:hlinkClick r:id="rId10"/>
+              </a:rPr>
+              <a:t>ScienceDirect</a:t>
+            </a:r>
+            <a:br>
+              <a:rPr lang="en-US" dirty="0"/>
+            </a:br>
+            <a:r>
+              <a:rPr lang="en-US" dirty="0"/>
+              <a:t>— Survey of optical flow techniques, challenges, recent innovations. Good for understanding what methods are available, strengths/weaknesses. </a:t>
+            </a:r>
+            <a:r>
+              <a:rPr lang="en-US" dirty="0">
+                <a:hlinkClick r:id="rId10"/>
+              </a:rPr>
+              <a:t>ScienceDirect</a:t>
+            </a:r>
+            <a:endParaRPr lang="en-US" dirty="0"/>
+          </a:p>
+          <a:p>
+            <a:pPr>
+              <a:buFont typeface="+mj-lt"/>
+              <a:buAutoNum type="arabicPeriod"/>
+            </a:pPr>
+            <a:r>
+              <a:rPr lang="en-US" i="1" dirty="0"/>
+              <a:t>Adaptive river flow measurement method based on spatiotemporal image velocimetry (STIV) and optical flow</a:t>
+            </a:r>
+            <a:r>
+              <a:rPr lang="en-US" dirty="0"/>
+              <a:t>. (2023). </a:t>
+            </a:r>
+            <a:r>
+              <a:rPr lang="en-US" dirty="0">
+                <a:hlinkClick r:id="rId11"/>
+              </a:rPr>
+              <a:t>iwaponline.com</a:t>
+            </a:r>
+            <a:br>
+              <a:rPr lang="en-US" dirty="0"/>
+            </a:br>
+            <a:r>
+              <a:rPr lang="en-US" dirty="0"/>
+              <a:t>— Application in hydrology: combines spatiotemporal image velocimetry with optical flow to handle real-environment conditions for measuring surface flow. </a:t>
+            </a:r>
+            <a:r>
+              <a:rPr lang="en-US" dirty="0">
+                <a:hlinkClick r:id="rId11"/>
+              </a:rPr>
+              <a:t>iwaponline.com</a:t>
+            </a:r>
+            <a:endParaRPr lang="en-US" dirty="0"/>
+          </a:p>
+          <a:p>
+            <a:pPr>
+              <a:buNone/>
+            </a:pPr>
+            <a:br>
+              <a:rPr lang="en-US" dirty="0"/>
+            </a:br>
+            <a:endParaRPr lang="en-US" dirty="0"/>
+          </a:p>
+          <a:p>
+            <a:pPr>
+              <a:buNone/>
+            </a:pPr>
+            <a:r>
+              <a:rPr lang="en-US" dirty="0"/>
+              <a:t>If you tell me whether your work is more </a:t>
+            </a:r>
+            <a:r>
+              <a:rPr lang="en-US" b="1" dirty="0"/>
+              <a:t>fluid mechanics / experimental physics</a:t>
+            </a:r>
+            <a:r>
+              <a:rPr lang="en-US" dirty="0"/>
+              <a:t> or more </a:t>
+            </a:r>
+            <a:r>
+              <a:rPr lang="en-US" b="1" dirty="0"/>
+              <a:t>robotics / computer vision</a:t>
+            </a:r>
+            <a:r>
+              <a:rPr lang="en-US" dirty="0"/>
+              <a:t>, I can pull together a more targeted list (or format these into APA/IEEE/MLA).</a:t>
+            </a:r>
+          </a:p>
+          <a:p>
+            <a:pPr>
+              <a:buNone/>
+            </a:pPr>
+            <a:r>
+              <a:rPr lang="en-US" b="1" dirty="0"/>
+              <a:t>You said:</a:t>
+            </a:r>
+          </a:p>
+          <a:p>
+            <a:pPr>
+              <a:buNone/>
+            </a:pPr>
+            <a:r>
+              <a:rPr lang="en-US" dirty="0"/>
+              <a:t>my work is more robotics and computer vision</a:t>
+            </a:r>
+          </a:p>
+          <a:p>
+            <a:pPr>
+              <a:buNone/>
+            </a:pPr>
+            <a:r>
+              <a:rPr lang="en-US" b="1" dirty="0"/>
+              <a:t>ChatGPT said:</a:t>
+            </a:r>
+          </a:p>
+          <a:p>
+            <a:pPr>
+              <a:buNone/>
+            </a:pPr>
+            <a:r>
+              <a:rPr lang="en-US" dirty="0"/>
+              <a:t>Perfect — in </a:t>
+            </a:r>
+            <a:r>
+              <a:rPr lang="en-US" b="1" dirty="0"/>
+              <a:t>robotics and computer vision</a:t>
+            </a:r>
+            <a:r>
+              <a:rPr lang="en-US" dirty="0"/>
+              <a:t>, visual velocimetry overlaps strongly with </a:t>
+            </a:r>
+            <a:r>
+              <a:rPr lang="en-US" b="1" dirty="0"/>
+              <a:t>optical flow</a:t>
+            </a:r>
+            <a:r>
+              <a:rPr lang="en-US" dirty="0"/>
+              <a:t>, </a:t>
+            </a:r>
+            <a:r>
+              <a:rPr lang="en-US" b="1" dirty="0"/>
+              <a:t>event-based vision</a:t>
+            </a:r>
+            <a:r>
+              <a:rPr lang="en-US" dirty="0"/>
+              <a:t>, and </a:t>
+            </a:r>
+            <a:r>
+              <a:rPr lang="en-US" b="1" dirty="0"/>
+              <a:t>learning-based PIV</a:t>
+            </a:r>
+            <a:r>
+              <a:rPr lang="en-US" dirty="0"/>
+              <a:t>. Here’s a curated list of </a:t>
+            </a:r>
+            <a:r>
+              <a:rPr lang="en-US" b="1" dirty="0"/>
+              <a:t>references most relevant for robotics &amp; CV applications</a:t>
+            </a:r>
+            <a:r>
+              <a:rPr lang="en-US" dirty="0"/>
+              <a:t>, rather than fluid mechanics.</a:t>
+            </a:r>
+          </a:p>
+          <a:p>
+            <a:pPr>
+              <a:buNone/>
+            </a:pPr>
+            <a:br>
+              <a:rPr lang="en-US" dirty="0"/>
+            </a:br>
+            <a:endParaRPr lang="en-US" dirty="0"/>
+          </a:p>
+          <a:p>
+            <a:pPr>
+              <a:buNone/>
+            </a:pPr>
+            <a:r>
+              <a:rPr lang="en-US" b="1" dirty="0"/>
+              <a:t>📌 Core References for Robotics &amp; Computer Vision</a:t>
+            </a:r>
+          </a:p>
+          <a:p>
+            <a:pPr>
+              <a:buFont typeface="+mj-lt"/>
+              <a:buAutoNum type="arabicPeriod"/>
+            </a:pPr>
+            <a:r>
+              <a:rPr lang="en-US" b="1" dirty="0"/>
+              <a:t>Horn, B. K. P., &amp; Schunck, B. G. (1981).</a:t>
+            </a:r>
+            <a:r>
+              <a:rPr lang="en-US" dirty="0"/>
+              <a:t> Determining optical flow. </a:t>
+            </a:r>
+            <a:r>
+              <a:rPr lang="en-US" i="1" dirty="0"/>
+              <a:t>Artificial Intelligence, 17</a:t>
+            </a:r>
+            <a:r>
+              <a:rPr lang="en-US" dirty="0"/>
+              <a:t>(1–3), 185–203.</a:t>
+            </a:r>
+            <a:br>
+              <a:rPr lang="en-US" dirty="0"/>
+            </a:br>
+            <a:r>
+              <a:rPr lang="en-US" dirty="0"/>
+              <a:t>— The classical variational optical flow method; foundation for many later approaches.</a:t>
+            </a:r>
+          </a:p>
+          <a:p>
+            <a:pPr>
+              <a:buFont typeface="+mj-lt"/>
+              <a:buAutoNum type="arabicPeriod"/>
+            </a:pPr>
+            <a:r>
+              <a:rPr lang="en-US" b="1" dirty="0"/>
+              <a:t>Lucas, B. D., &amp; Kanade, T. (1981).</a:t>
+            </a:r>
+            <a:r>
+              <a:rPr lang="en-US" dirty="0"/>
+              <a:t> An iterative image registration technique with an application to stereo vision. </a:t>
+            </a:r>
+            <a:r>
+              <a:rPr lang="en-US" i="1" dirty="0"/>
+              <a:t>Proceedings of Imaging Understanding Workshop</a:t>
+            </a:r>
+            <a:r>
+              <a:rPr lang="en-US" dirty="0"/>
+              <a:t>.</a:t>
+            </a:r>
+            <a:br>
+              <a:rPr lang="en-US" dirty="0"/>
+            </a:br>
+            <a:r>
+              <a:rPr lang="en-US" dirty="0"/>
+              <a:t>— Lucas–Kanade tracker, a cornerstone for sparse optical flow in robotics.</a:t>
+            </a:r>
+          </a:p>
+          <a:p>
+            <a:pPr>
+              <a:buFont typeface="+mj-lt"/>
+              <a:buAutoNum type="arabicPeriod"/>
+            </a:pPr>
+            <a:r>
+              <a:rPr lang="en-US" b="1" dirty="0" err="1"/>
+              <a:t>Farnebäck</a:t>
+            </a:r>
+            <a:r>
+              <a:rPr lang="en-US" b="1" dirty="0"/>
+              <a:t>, G. (2003).</a:t>
+            </a:r>
+            <a:r>
+              <a:rPr lang="en-US" dirty="0"/>
+              <a:t> Two-frame motion estimation based on polynomial expansion. </a:t>
+            </a:r>
+            <a:r>
+              <a:rPr lang="en-US" i="1" dirty="0"/>
+              <a:t>Proceedings of the 13th Scandinavian Conference on Image Analysis (SCIA)</a:t>
+            </a:r>
+            <a:r>
+              <a:rPr lang="en-US" dirty="0"/>
+              <a:t>, 363–370.</a:t>
+            </a:r>
+            <a:br>
+              <a:rPr lang="en-US" dirty="0"/>
+            </a:br>
+            <a:r>
+              <a:rPr lang="en-US" dirty="0"/>
+              <a:t>— Dense optical flow widely used in robotics (implemented in OpenCV).</a:t>
+            </a:r>
+          </a:p>
+          <a:p>
+            <a:pPr>
+              <a:buFont typeface="+mj-lt"/>
+              <a:buAutoNum type="arabicPeriod"/>
+            </a:pPr>
+            <a:r>
+              <a:rPr lang="en-US" b="1" dirty="0" err="1"/>
+              <a:t>Dosovitskiy</a:t>
+            </a:r>
+            <a:r>
+              <a:rPr lang="en-US" b="1" dirty="0"/>
+              <a:t>, A., Fischer, P., Ilg, E., et al. (2015).</a:t>
+            </a:r>
+            <a:r>
+              <a:rPr lang="en-US" dirty="0"/>
+              <a:t> </a:t>
+            </a:r>
+            <a:r>
+              <a:rPr lang="en-US" dirty="0" err="1"/>
+              <a:t>FlowNet</a:t>
+            </a:r>
+            <a:r>
+              <a:rPr lang="en-US" dirty="0"/>
+              <a:t>: Learning optical flow with convolutional networks. </a:t>
+            </a:r>
+            <a:r>
+              <a:rPr lang="en-US" i="1" dirty="0"/>
+              <a:t>Proceedings of the IEEE International Conference on Computer Vision (ICCV)</a:t>
+            </a:r>
+            <a:r>
+              <a:rPr lang="en-US" dirty="0"/>
+              <a:t>, 2758–2766.</a:t>
+            </a:r>
+            <a:br>
+              <a:rPr lang="en-US" dirty="0"/>
+            </a:br>
+            <a:r>
+              <a:rPr lang="en-US" dirty="0"/>
+              <a:t>— First deep CNN to directly estimate dense optical flow.</a:t>
+            </a:r>
+          </a:p>
+          <a:p>
+            <a:pPr>
+              <a:buFont typeface="+mj-lt"/>
+              <a:buAutoNum type="arabicPeriod"/>
+            </a:pPr>
+            <a:r>
+              <a:rPr lang="en-US" b="1" dirty="0"/>
+              <a:t>Ilg, E., Mayer, N., Saikia, T., et al. (2017).</a:t>
+            </a:r>
+            <a:r>
+              <a:rPr lang="en-US" dirty="0"/>
+              <a:t> </a:t>
+            </a:r>
+            <a:r>
+              <a:rPr lang="en-US" dirty="0" err="1"/>
+              <a:t>FlowNet</a:t>
+            </a:r>
+            <a:r>
+              <a:rPr lang="en-US" dirty="0"/>
+              <a:t> 2.0: Evolution of optical flow estimation with deep networks. </a:t>
+            </a:r>
+            <a:r>
+              <a:rPr lang="en-US" i="1" dirty="0"/>
+              <a:t>Proceedings of the IEEE Conference on Computer Vision and Pattern Recognition (CVPR)</a:t>
+            </a:r>
+            <a:r>
+              <a:rPr lang="en-US" dirty="0"/>
+              <a:t>, 1647–1655.</a:t>
+            </a:r>
+            <a:br>
+              <a:rPr lang="en-US" dirty="0"/>
+            </a:br>
+            <a:r>
+              <a:rPr lang="en-US" dirty="0"/>
+              <a:t>— More accurate stacked architecture, benchmark in robotics.</a:t>
+            </a:r>
+          </a:p>
+          <a:p>
+            <a:pPr>
+              <a:buFont typeface="+mj-lt"/>
+              <a:buAutoNum type="arabicPeriod"/>
+            </a:pPr>
+            <a:r>
+              <a:rPr lang="en-US" b="1" dirty="0"/>
+              <a:t>Teed, Z., &amp; Deng, J. (2020).</a:t>
+            </a:r>
+            <a:r>
+              <a:rPr lang="en-US" dirty="0"/>
+              <a:t> RAFT: Recurrent all-pairs field transforms for optical flow. </a:t>
+            </a:r>
+            <a:r>
+              <a:rPr lang="en-US" i="1" dirty="0"/>
+              <a:t>European Conference on Computer Vision (ECCV)</a:t>
+            </a:r>
+            <a:r>
+              <a:rPr lang="en-US" dirty="0"/>
+              <a:t>, 402–419.</a:t>
+            </a:r>
+            <a:br>
+              <a:rPr lang="en-US" dirty="0"/>
+            </a:br>
+            <a:r>
+              <a:rPr lang="en-US" dirty="0"/>
+              <a:t>— A state-of-the-art network for dense flow; widely adopted in robotic perception.</a:t>
+            </a:r>
+          </a:p>
+          <a:p>
+            <a:pPr>
+              <a:buFont typeface="+mj-lt"/>
+              <a:buAutoNum type="arabicPeriod"/>
+            </a:pPr>
+            <a:r>
+              <a:rPr lang="en-US" b="1" dirty="0"/>
+              <a:t>Gallego, G., Delbrück, T., Orchard, G., et al. (2020).</a:t>
+            </a:r>
+            <a:r>
+              <a:rPr lang="en-US" dirty="0"/>
+              <a:t> Event-based vision: A survey. </a:t>
+            </a:r>
+            <a:r>
+              <a:rPr lang="en-US" i="1" dirty="0"/>
+              <a:t>IEEE Transactions on Pattern Analysis and Machine Intelligence, 44</a:t>
+            </a:r>
+            <a:r>
+              <a:rPr lang="en-US" dirty="0"/>
+              <a:t>(1), 154–180.</a:t>
+            </a:r>
+            <a:br>
+              <a:rPr lang="en-US" dirty="0"/>
+            </a:br>
+            <a:r>
+              <a:rPr lang="en-US" dirty="0"/>
+              <a:t>— Comprehensive review of event cameras and their use for high-speed visual flow/velocity estimation.</a:t>
+            </a:r>
+          </a:p>
+          <a:p>
+            <a:pPr>
+              <a:buFont typeface="+mj-lt"/>
+              <a:buAutoNum type="arabicPeriod"/>
+            </a:pPr>
+            <a:r>
+              <a:rPr lang="en-US" b="1" dirty="0" err="1"/>
+              <a:t>Rebecq</a:t>
+            </a:r>
+            <a:r>
+              <a:rPr lang="en-US" b="1" dirty="0"/>
+              <a:t>, H., Gehrig, D., &amp; </a:t>
+            </a:r>
+            <a:r>
+              <a:rPr lang="en-US" b="1" dirty="0" err="1"/>
+              <a:t>Scaramuzza</a:t>
+            </a:r>
+            <a:r>
+              <a:rPr lang="en-US" b="1" dirty="0"/>
+              <a:t>, D. (2019).</a:t>
+            </a:r>
+            <a:r>
+              <a:rPr lang="en-US" dirty="0"/>
+              <a:t> ESIM: An open event camera simulator. </a:t>
+            </a:r>
+            <a:r>
+              <a:rPr lang="en-US" i="1" dirty="0"/>
+              <a:t>Conference on Robotics and Automation (ICRA)</a:t>
+            </a:r>
+            <a:r>
+              <a:rPr lang="en-US" dirty="0"/>
+              <a:t>.</a:t>
+            </a:r>
+            <a:br>
+              <a:rPr lang="en-US" dirty="0"/>
+            </a:br>
+            <a:r>
+              <a:rPr lang="en-US" dirty="0"/>
+              <a:t>— Enables training/testing of visual velocimetry algorithms on synthetic event data.</a:t>
+            </a:r>
+          </a:p>
+          <a:p>
+            <a:pPr>
+              <a:buFont typeface="+mj-lt"/>
+              <a:buAutoNum type="arabicPeriod"/>
+            </a:pPr>
+            <a:r>
+              <a:rPr lang="en-US" b="1" dirty="0"/>
+              <a:t>Willert, C., &amp; Klinner, J. (2022).</a:t>
+            </a:r>
+            <a:r>
+              <a:rPr lang="en-US" dirty="0"/>
+              <a:t> Event-based imaging velocimetry. </a:t>
+            </a:r>
+            <a:r>
+              <a:rPr lang="en-US" i="1" dirty="0"/>
+              <a:t>arXiv:2202.11178</a:t>
+            </a:r>
+            <a:r>
+              <a:rPr lang="en-US" dirty="0"/>
+              <a:t>.</a:t>
+            </a:r>
+            <a:br>
+              <a:rPr lang="en-US" dirty="0"/>
+            </a:br>
+            <a:r>
+              <a:rPr lang="en-US" dirty="0"/>
+              <a:t>— Adapts event cameras specifically for visual velocimetry tasks, suitable for robotics.</a:t>
+            </a:r>
+          </a:p>
+          <a:p>
+            <a:pPr>
+              <a:buFont typeface="+mj-lt"/>
+              <a:buAutoNum type="arabicPeriod"/>
+            </a:pPr>
+            <a:r>
+              <a:rPr lang="en-US" b="1" dirty="0"/>
+              <a:t>Masker, A. I., Zhou, K., Molnar, J. P., &amp; Grauer, S. J. (2024).</a:t>
+            </a:r>
+            <a:r>
+              <a:rPr lang="en-US" dirty="0"/>
+              <a:t> Neural optical flow for planar and stereo PIV. </a:t>
+            </a:r>
+            <a:r>
+              <a:rPr lang="en-US" i="1" dirty="0"/>
+              <a:t>arXiv:2411.02373</a:t>
+            </a:r>
+            <a:r>
+              <a:rPr lang="en-US" dirty="0"/>
+              <a:t>.</a:t>
+            </a:r>
+            <a:br>
+              <a:rPr lang="en-US" dirty="0"/>
+            </a:br>
+            <a:r>
+              <a:rPr lang="en-US" dirty="0"/>
+              <a:t>— Bridges particle image velocimetry with neural optical flow, extending applicability to robotics perception scenarios.</a:t>
+            </a:r>
+          </a:p>
+          <a:p>
+            <a:pPr>
+              <a:buNone/>
+            </a:pPr>
+            <a:br>
+              <a:rPr lang="en-US" dirty="0"/>
+            </a:br>
+            <a:endParaRPr lang="en-US" dirty="0"/>
+          </a:p>
+          <a:p>
+            <a:pPr>
+              <a:buNone/>
+            </a:pPr>
+            <a:r>
+              <a:rPr lang="en-US" b="1" dirty="0"/>
+              <a:t>📌 Why these matter for robotics</a:t>
+            </a:r>
+          </a:p>
+          <a:p>
+            <a:pPr>
+              <a:buFont typeface="Arial" panose="020B0604020202020204" pitchFamily="34" charset="0"/>
+              <a:buChar char="•"/>
+            </a:pPr>
+            <a:r>
+              <a:rPr lang="en-US" b="1" dirty="0"/>
+              <a:t>Horn–Schunck / Lucas–Kanade / </a:t>
+            </a:r>
+            <a:r>
+              <a:rPr lang="en-US" b="1" dirty="0" err="1"/>
+              <a:t>Farnebäck</a:t>
+            </a:r>
+            <a:r>
+              <a:rPr lang="en-US" dirty="0"/>
+              <a:t> → Classic algorithms still used in embedded vision (e.g., drones, autonomous robots).</a:t>
+            </a:r>
+          </a:p>
+          <a:p>
+            <a:pPr>
+              <a:buFont typeface="Arial" panose="020B0604020202020204" pitchFamily="34" charset="0"/>
+              <a:buChar char="•"/>
+            </a:pPr>
+            <a:r>
+              <a:rPr lang="en-US" b="1" dirty="0" err="1"/>
+              <a:t>FlowNet</a:t>
+            </a:r>
+            <a:r>
+              <a:rPr lang="en-US" b="1" dirty="0"/>
+              <a:t> / FlowNet2 / RAFT</a:t>
+            </a:r>
+            <a:r>
+              <a:rPr lang="en-US" dirty="0"/>
+              <a:t> → Deep learning breakthroughs enabling robust, dense, and generalizable velocity estimation.</a:t>
+            </a:r>
+          </a:p>
+          <a:p>
+            <a:pPr>
+              <a:buFont typeface="Arial" panose="020B0604020202020204" pitchFamily="34" charset="0"/>
+              <a:buChar char="•"/>
+            </a:pPr>
+            <a:r>
+              <a:rPr lang="en-US" b="1" dirty="0"/>
+              <a:t>Event-based vision works</a:t>
+            </a:r>
+            <a:r>
+              <a:rPr lang="en-US" dirty="0"/>
+              <a:t> → Critical for robotics in high-speed, high-dynamic-range environments where standard cameras fail.</a:t>
+            </a:r>
+          </a:p>
+          <a:p>
+            <a:pPr>
+              <a:buFont typeface="Arial" panose="020B0604020202020204" pitchFamily="34" charset="0"/>
+              <a:buChar char="•"/>
+            </a:pPr>
+            <a:r>
+              <a:rPr lang="en-US" b="1" dirty="0"/>
+              <a:t>Neural PIV &amp; hybrid methods</a:t>
+            </a:r>
+            <a:r>
+              <a:rPr lang="en-US" dirty="0"/>
+              <a:t> → Emerging frontier where robotics overlaps with experimental flow measurement.</a:t>
+            </a:r>
+          </a:p>
+        </p:txBody>
+      </p:sp>
     </p:spTree>
+  </p:cSld>
+  <p:clrMapOvr>
+    <a:masterClrMapping/>
+  </p:clrMapOvr>
+</p:sld>
+</file>
+
+<file path=ppt/slides/slide19.xml><?xml version="1.0" encoding="utf-8"?>
+<p:sld xmlns:a="http://schemas.openxmlformats.org/drawingml/2006/main" xmlns:r="http://schemas.openxmlformats.org/officeDocument/2006/relationships" xmlns:p="http://schemas.openxmlformats.org/presentationml/2006/main">
+  <p:cSld>
+    <p:spTree>
+      <p:nvGrpSpPr>
+        <p:cNvPr id="1" name="Shape 186">
+          <a:extLst>
+            <a:ext uri="{FF2B5EF4-FFF2-40B4-BE49-F238E27FC236}">
+              <a16:creationId xmlns:a16="http://schemas.microsoft.com/office/drawing/2014/main" id="{55E7C942-46DA-6896-5275-05A6F8C40085}"/>
+            </a:ext>
+          </a:extLst>
+        </p:cNvPr>
+        <p:cNvGrpSpPr/>
+        <p:nvPr/>
+      </p:nvGrpSpPr>
+      <p:grpSpPr>
+        <a:xfrm>
+          <a:off x="0" y="0"/>
+          <a:ext cx="0" cy="0"/>
+          <a:chOff x="0" y="0"/>
+          <a:chExt cx="0" cy="0"/>
+        </a:xfrm>
+      </p:grpSpPr>
+      <p:sp>
+        <p:nvSpPr>
+          <p:cNvPr id="187" name="Google Shape;187;p30">
+            <a:extLst>
+              <a:ext uri="{FF2B5EF4-FFF2-40B4-BE49-F238E27FC236}">
+                <a16:creationId xmlns:a16="http://schemas.microsoft.com/office/drawing/2014/main" id="{39E6F45D-A0C2-2621-A6E1-60B4585BC3F2}"/>
+              </a:ext>
+            </a:extLst>
+          </p:cNvPr>
+          <p:cNvSpPr txBox="1">
+            <a:spLocks noGrp="1"/>
+          </p:cNvSpPr>
+          <p:nvPr>
+            <p:ph type="ctrTitle"/>
+          </p:nvPr>
+        </p:nvSpPr>
+        <p:spPr>
+          <a:xfrm>
+            <a:off x="311700" y="744575"/>
+            <a:ext cx="8520600" cy="740700"/>
+          </a:xfrm>
+          <a:prstGeom prst="rect">
+            <a:avLst/>
+          </a:prstGeom>
+        </p:spPr>
+        <p:txBody>
+          <a:bodyPr spcFirstLastPara="1" wrap="square" lIns="91425" tIns="91425" rIns="91425" bIns="91425" anchor="b" anchorCtr="0">
+            <a:normAutofit fontScale="90000"/>
+          </a:bodyPr>
+          <a:lstStyle/>
+          <a:p>
+            <a:pPr marL="0" lvl="0" indent="0" algn="ctr" rtl="0">
+              <a:spcBef>
+                <a:spcPts val="0"/>
+              </a:spcBef>
+              <a:spcAft>
+                <a:spcPts val="0"/>
+              </a:spcAft>
+              <a:buNone/>
+            </a:pPr>
+            <a:r>
+              <a:rPr lang="en" dirty="0">
+                <a:latin typeface="Calibri"/>
+                <a:ea typeface="Calibri"/>
+                <a:cs typeface="Calibri"/>
+                <a:sym typeface="Calibri"/>
+              </a:rPr>
+              <a:t>References 1-6: Velocimetry</a:t>
+            </a:r>
+            <a:endParaRPr dirty="0">
+              <a:latin typeface="Calibri"/>
+              <a:ea typeface="Calibri"/>
+              <a:cs typeface="Calibri"/>
+              <a:sym typeface="Calibri"/>
+            </a:endParaRPr>
+          </a:p>
+        </p:txBody>
+      </p:sp>
+      <p:sp>
+        <p:nvSpPr>
+          <p:cNvPr id="5" name="TextBox 4">
+            <a:extLst>
+              <a:ext uri="{FF2B5EF4-FFF2-40B4-BE49-F238E27FC236}">
+                <a16:creationId xmlns:a16="http://schemas.microsoft.com/office/drawing/2014/main" id="{438AD2CD-137F-9ECD-B978-16161E97C4D3}"/>
+              </a:ext>
+            </a:extLst>
+          </p:cNvPr>
+          <p:cNvSpPr txBox="1"/>
+          <p:nvPr/>
+        </p:nvSpPr>
+        <p:spPr>
+          <a:xfrm>
+            <a:off x="463550" y="1633538"/>
+            <a:ext cx="8223250" cy="3108543"/>
+          </a:xfrm>
+          <a:prstGeom prst="rect">
+            <a:avLst/>
+          </a:prstGeom>
+          <a:noFill/>
+        </p:spPr>
+        <p:txBody>
+          <a:bodyPr wrap="square">
+            <a:spAutoFit/>
+          </a:bodyPr>
+          <a:lstStyle/>
+          <a:p>
+            <a:r>
+              <a:rPr lang="en-US" dirty="0"/>
+              <a:t>[1] P. Viola and M. Jones, "Rapid object detection using a boosted cascade of simple features," in </a:t>
+            </a:r>
+            <a:r>
+              <a:rPr lang="en-US" i="1" dirty="0"/>
+              <a:t>Proc. IEEE Conf. </a:t>
+            </a:r>
+            <a:r>
+              <a:rPr lang="en-US" i="1" dirty="0" err="1"/>
+              <a:t>Comput</a:t>
+            </a:r>
+            <a:r>
+              <a:rPr lang="en-US" i="1" dirty="0"/>
+              <a:t>. Vis. Pattern </a:t>
+            </a:r>
+            <a:r>
+              <a:rPr lang="en-US" i="1" dirty="0" err="1"/>
+              <a:t>Recognit</a:t>
+            </a:r>
+            <a:r>
+              <a:rPr lang="en-US" i="1" dirty="0"/>
+              <a:t>. (CVPR)</a:t>
+            </a:r>
+            <a:r>
+              <a:rPr lang="en-US" dirty="0"/>
+              <a:t>, 2001, pp. I–I.</a:t>
+            </a:r>
+            <a:br>
+              <a:rPr lang="en-US" dirty="0"/>
+            </a:br>
+            <a:r>
+              <a:rPr lang="en-US" dirty="0"/>
+              <a:t>[2] N. Dalal and B. Triggs, "Histograms of oriented gradients for human detection," in </a:t>
+            </a:r>
+            <a:r>
+              <a:rPr lang="en-US" i="1" dirty="0"/>
+              <a:t>Proc. IEEE Conf. </a:t>
+            </a:r>
+            <a:r>
+              <a:rPr lang="en-US" i="1" dirty="0" err="1"/>
+              <a:t>Comput</a:t>
+            </a:r>
+            <a:r>
+              <a:rPr lang="en-US" i="1" dirty="0"/>
+              <a:t>. Vis. Pattern </a:t>
+            </a:r>
+            <a:r>
+              <a:rPr lang="en-US" i="1" dirty="0" err="1"/>
+              <a:t>Recognit</a:t>
+            </a:r>
+            <a:r>
+              <a:rPr lang="en-US" i="1" dirty="0"/>
+              <a:t>. (CVPR)</a:t>
+            </a:r>
+            <a:r>
+              <a:rPr lang="en-US" dirty="0"/>
+              <a:t>, vol. 1, 2005, pp. 886–893.</a:t>
+            </a:r>
+            <a:br>
+              <a:rPr lang="en-US" dirty="0"/>
+            </a:br>
+            <a:r>
+              <a:rPr lang="en-US" dirty="0"/>
+              <a:t>[3] P. F. </a:t>
+            </a:r>
+            <a:r>
+              <a:rPr lang="en-US" dirty="0" err="1"/>
+              <a:t>Felzenszwalb</a:t>
+            </a:r>
+            <a:r>
+              <a:rPr lang="en-US" dirty="0"/>
+              <a:t>, R. B. </a:t>
+            </a:r>
+            <a:r>
+              <a:rPr lang="en-US" dirty="0" err="1"/>
+              <a:t>Girshick</a:t>
+            </a:r>
+            <a:r>
+              <a:rPr lang="en-US" dirty="0"/>
+              <a:t>, D. McAllester, and D. Ramanan, "Object detection with discriminatively trained part-based models," </a:t>
+            </a:r>
+            <a:r>
+              <a:rPr lang="en-US" i="1" dirty="0"/>
+              <a:t>IEEE Trans. Pattern Anal. Mach. </a:t>
+            </a:r>
+            <a:r>
+              <a:rPr lang="en-US" i="1" dirty="0" err="1"/>
+              <a:t>Intell</a:t>
+            </a:r>
+            <a:r>
+              <a:rPr lang="en-US" i="1" dirty="0"/>
+              <a:t>.</a:t>
+            </a:r>
+            <a:r>
+              <a:rPr lang="en-US" dirty="0"/>
+              <a:t>, vol. 32, no. 9, pp. 1627–1645, 2010.</a:t>
+            </a:r>
+            <a:br>
+              <a:rPr lang="en-US" dirty="0"/>
+            </a:br>
+            <a:r>
+              <a:rPr lang="en-US" dirty="0"/>
+              <a:t>[4] A. </a:t>
+            </a:r>
+            <a:r>
+              <a:rPr lang="en-US" dirty="0" err="1"/>
+              <a:t>Krizhevsky</a:t>
+            </a:r>
+            <a:r>
+              <a:rPr lang="en-US" dirty="0"/>
+              <a:t>, I. </a:t>
+            </a:r>
+            <a:r>
+              <a:rPr lang="en-US" dirty="0" err="1"/>
+              <a:t>Sutskever</a:t>
+            </a:r>
+            <a:r>
+              <a:rPr lang="en-US" dirty="0"/>
+              <a:t>, and G. E. Hinton, "ImageNet classification with deep convolutional neural networks," in </a:t>
+            </a:r>
+            <a:r>
+              <a:rPr lang="en-US" i="1" dirty="0"/>
+              <a:t>Adv. Neural Inf. Process. Syst.</a:t>
+            </a:r>
+            <a:r>
+              <a:rPr lang="en-US" dirty="0"/>
+              <a:t>, vol. 25, 2012.</a:t>
+            </a:r>
+            <a:br>
+              <a:rPr lang="en-US" dirty="0"/>
+            </a:br>
+            <a:r>
+              <a:rPr lang="en-US" dirty="0"/>
+              <a:t>[5] R. </a:t>
+            </a:r>
+            <a:r>
+              <a:rPr lang="en-US" dirty="0" err="1"/>
+              <a:t>Girshick</a:t>
+            </a:r>
+            <a:r>
+              <a:rPr lang="en-US" dirty="0"/>
+              <a:t>, J. Donahue, T. Darrell, and J. Malik, "Rich feature hierarchies for accurate object detection and semantic segmentation," in </a:t>
+            </a:r>
+            <a:r>
+              <a:rPr lang="en-US" i="1" dirty="0"/>
+              <a:t>Proc. IEEE Conf. </a:t>
+            </a:r>
+            <a:r>
+              <a:rPr lang="en-US" i="1" dirty="0" err="1"/>
+              <a:t>Comput</a:t>
+            </a:r>
+            <a:r>
+              <a:rPr lang="en-US" i="1" dirty="0"/>
+              <a:t>. Vis. Pattern </a:t>
+            </a:r>
+            <a:r>
+              <a:rPr lang="en-US" i="1" dirty="0" err="1"/>
+              <a:t>Recognit</a:t>
+            </a:r>
+            <a:r>
+              <a:rPr lang="en-US" i="1" dirty="0"/>
+              <a:t>. (CVPR)</a:t>
+            </a:r>
+            <a:r>
+              <a:rPr lang="en-US" dirty="0"/>
+              <a:t>, 2014, pp. 580–587.</a:t>
+            </a:r>
+            <a:br>
+              <a:rPr lang="en-US" dirty="0"/>
+            </a:br>
+            <a:r>
+              <a:rPr lang="en-US" dirty="0"/>
+              <a:t>[6] R. </a:t>
+            </a:r>
+            <a:r>
+              <a:rPr lang="en-US" dirty="0" err="1"/>
+              <a:t>Girshick</a:t>
+            </a:r>
+            <a:r>
+              <a:rPr lang="en-US" dirty="0"/>
+              <a:t>, "Fast R-CNN," in </a:t>
+            </a:r>
+            <a:r>
+              <a:rPr lang="en-US" i="1" dirty="0"/>
+              <a:t>Proc. IEEE Int. Conf. </a:t>
+            </a:r>
+            <a:r>
+              <a:rPr lang="en-US" i="1" dirty="0" err="1"/>
+              <a:t>Comput</a:t>
+            </a:r>
+            <a:r>
+              <a:rPr lang="en-US" i="1" dirty="0"/>
+              <a:t>. Vis. (ICCV)</a:t>
+            </a:r>
+            <a:r>
+              <a:rPr lang="en-US" dirty="0"/>
+              <a:t>, 2015, pp. 1440–1448.</a:t>
+            </a:r>
+            <a:br>
+              <a:rPr lang="en-US" dirty="0"/>
+            </a:br>
+            <a:endParaRPr lang="en-US" dirty="0"/>
+          </a:p>
+        </p:txBody>
+      </p:sp>
+    </p:spTree>
+    <p:extLst>
+      <p:ext uri="{BB962C8B-B14F-4D97-AF65-F5344CB8AC3E}">
+        <p14:creationId xmlns:p14="http://schemas.microsoft.com/office/powerpoint/2010/main" val="1952350450"/>
+      </p:ext>
+    </p:extLst>
   </p:cSld>
   <p:clrMapOvr>
     <a:masterClrMapping/>
@@ -9214,6 +10722,238 @@
         </p:txBody>
       </p:sp>
     </p:spTree>
+  </p:cSld>
+  <p:clrMapOvr>
+    <a:masterClrMapping/>
+  </p:clrMapOvr>
+</p:sld>
+</file>
+
+<file path=ppt/slides/slide20.xml><?xml version="1.0" encoding="utf-8"?>
+<p:sld xmlns:a="http://schemas.openxmlformats.org/drawingml/2006/main" xmlns:r="http://schemas.openxmlformats.org/officeDocument/2006/relationships" xmlns:p="http://schemas.openxmlformats.org/presentationml/2006/main">
+  <p:cSld>
+    <p:spTree>
+      <p:nvGrpSpPr>
+        <p:cNvPr id="1" name="Shape 186">
+          <a:extLst>
+            <a:ext uri="{FF2B5EF4-FFF2-40B4-BE49-F238E27FC236}">
+              <a16:creationId xmlns:a16="http://schemas.microsoft.com/office/drawing/2014/main" id="{0A1BBDA7-4AE2-206D-0625-F24DEBB57687}"/>
+            </a:ext>
+          </a:extLst>
+        </p:cNvPr>
+        <p:cNvGrpSpPr/>
+        <p:nvPr/>
+      </p:nvGrpSpPr>
+      <p:grpSpPr>
+        <a:xfrm>
+          <a:off x="0" y="0"/>
+          <a:ext cx="0" cy="0"/>
+          <a:chOff x="0" y="0"/>
+          <a:chExt cx="0" cy="0"/>
+        </a:xfrm>
+      </p:grpSpPr>
+      <p:sp>
+        <p:nvSpPr>
+          <p:cNvPr id="187" name="Google Shape;187;p30">
+            <a:extLst>
+              <a:ext uri="{FF2B5EF4-FFF2-40B4-BE49-F238E27FC236}">
+                <a16:creationId xmlns:a16="http://schemas.microsoft.com/office/drawing/2014/main" id="{62632683-49A9-DDF7-CE16-3FE4154E7D91}"/>
+              </a:ext>
+            </a:extLst>
+          </p:cNvPr>
+          <p:cNvSpPr txBox="1">
+            <a:spLocks noGrp="1"/>
+          </p:cNvSpPr>
+          <p:nvPr>
+            <p:ph type="ctrTitle"/>
+          </p:nvPr>
+        </p:nvSpPr>
+        <p:spPr>
+          <a:xfrm>
+            <a:off x="311700" y="744575"/>
+            <a:ext cx="8520600" cy="740700"/>
+          </a:xfrm>
+          <a:prstGeom prst="rect">
+            <a:avLst/>
+          </a:prstGeom>
+        </p:spPr>
+        <p:txBody>
+          <a:bodyPr spcFirstLastPara="1" wrap="square" lIns="91425" tIns="91425" rIns="91425" bIns="91425" anchor="b" anchorCtr="0">
+            <a:normAutofit fontScale="90000"/>
+          </a:bodyPr>
+          <a:lstStyle/>
+          <a:p>
+            <a:pPr marL="0" lvl="0" indent="0" algn="ctr" rtl="0">
+              <a:spcBef>
+                <a:spcPts val="0"/>
+              </a:spcBef>
+              <a:spcAft>
+                <a:spcPts val="0"/>
+              </a:spcAft>
+              <a:buNone/>
+            </a:pPr>
+            <a:r>
+              <a:rPr lang="en" dirty="0">
+                <a:latin typeface="Calibri"/>
+                <a:ea typeface="Calibri"/>
+                <a:cs typeface="Calibri"/>
+                <a:sym typeface="Calibri"/>
+              </a:rPr>
+              <a:t>References 7-10: Velocimetry</a:t>
+            </a:r>
+            <a:endParaRPr dirty="0">
+              <a:latin typeface="Calibri"/>
+              <a:ea typeface="Calibri"/>
+              <a:cs typeface="Calibri"/>
+              <a:sym typeface="Calibri"/>
+            </a:endParaRPr>
+          </a:p>
+        </p:txBody>
+      </p:sp>
+      <p:sp>
+        <p:nvSpPr>
+          <p:cNvPr id="3" name="TextBox 2">
+            <a:extLst>
+              <a:ext uri="{FF2B5EF4-FFF2-40B4-BE49-F238E27FC236}">
+                <a16:creationId xmlns:a16="http://schemas.microsoft.com/office/drawing/2014/main" id="{1804CC2C-DF08-829A-BA0E-4D60955C0848}"/>
+              </a:ext>
+            </a:extLst>
+          </p:cNvPr>
+          <p:cNvSpPr txBox="1"/>
+          <p:nvPr/>
+        </p:nvSpPr>
+        <p:spPr>
+          <a:xfrm>
+            <a:off x="463550" y="1888511"/>
+            <a:ext cx="8223249" cy="2246769"/>
+          </a:xfrm>
+          <a:prstGeom prst="rect">
+            <a:avLst/>
+          </a:prstGeom>
+          <a:noFill/>
+        </p:spPr>
+        <p:txBody>
+          <a:bodyPr wrap="square">
+            <a:spAutoFit/>
+          </a:bodyPr>
+          <a:lstStyle/>
+          <a:p>
+            <a:pPr>
+              <a:buNone/>
+            </a:pPr>
+            <a:r>
+              <a:rPr lang="en-US" dirty="0"/>
+              <a:t>[7] G. Gallego, T. Delbrück, G. Orchard, et al., "Event-based vision: A survey," </a:t>
+            </a:r>
+            <a:r>
+              <a:rPr lang="en-US" i="1" dirty="0"/>
+              <a:t>IEEE Trans. Pattern Anal. Mach. </a:t>
+            </a:r>
+            <a:r>
+              <a:rPr lang="en-US" i="1" dirty="0" err="1"/>
+              <a:t>Intell</a:t>
+            </a:r>
+            <a:r>
+              <a:rPr lang="en-US" i="1" dirty="0"/>
+              <a:t>.</a:t>
+            </a:r>
+            <a:r>
+              <a:rPr lang="en-US" dirty="0"/>
+              <a:t>, vol. 44, no. 1, pp. 154–180, 2020.</a:t>
+            </a:r>
+          </a:p>
+          <a:p>
+            <a:pPr>
+              <a:buNone/>
+            </a:pPr>
+            <a:r>
+              <a:rPr lang="en-US" dirty="0"/>
+              <a:t>[8] H. </a:t>
+            </a:r>
+            <a:r>
+              <a:rPr lang="en-US" dirty="0" err="1"/>
+              <a:t>Rebecq</a:t>
+            </a:r>
+            <a:r>
+              <a:rPr lang="en-US" dirty="0"/>
+              <a:t>, D. Gehrig, and D. </a:t>
+            </a:r>
+            <a:r>
+              <a:rPr lang="en-US" dirty="0" err="1"/>
+              <a:t>Scaramuzza</a:t>
+            </a:r>
+            <a:r>
+              <a:rPr lang="en-US" dirty="0"/>
+              <a:t>, "ESIM: An open event camera simulator," in </a:t>
+            </a:r>
+            <a:r>
+              <a:rPr lang="en-US" i="1" dirty="0"/>
+              <a:t>Proc. IEEE Int. Conf. Robot. Autom. (ICRA)</a:t>
+            </a:r>
+            <a:r>
+              <a:rPr lang="en-US" dirty="0"/>
+              <a:t>, 2019.</a:t>
+            </a:r>
+          </a:p>
+          <a:p>
+            <a:pPr>
+              <a:buNone/>
+            </a:pPr>
+            <a:r>
+              <a:rPr lang="en-US" dirty="0"/>
+              <a:t>[9] C. Willert and J. Klinner, "Event-based imaging velocimetry—An assessment of event-based cameras for the measurement of fluid flows," </a:t>
+            </a:r>
+            <a:r>
+              <a:rPr lang="en-US" i="1" dirty="0" err="1"/>
+              <a:t>arXiv</a:t>
+            </a:r>
+            <a:r>
+              <a:rPr lang="en-US" i="1" dirty="0"/>
+              <a:t> preprint arXiv:2202.11178</a:t>
+            </a:r>
+            <a:r>
+              <a:rPr lang="en-US" dirty="0"/>
+              <a:t>, 2022.</a:t>
+            </a:r>
+          </a:p>
+          <a:p>
+            <a:pPr>
+              <a:buNone/>
+            </a:pPr>
+            <a:r>
+              <a:rPr lang="en-US" dirty="0"/>
+              <a:t>[10] A. I. Masker, K. Zhou, J. P. Molnar, and S. J. Grauer, "Neural optical flow for planar and stereo PIV," </a:t>
+            </a:r>
+            <a:r>
+              <a:rPr lang="en-US" i="1" dirty="0" err="1"/>
+              <a:t>arXiv</a:t>
+            </a:r>
+            <a:r>
+              <a:rPr lang="en-US" i="1" dirty="0"/>
+              <a:t> preprint arXiv:2411.02373</a:t>
+            </a:r>
+            <a:r>
+              <a:rPr lang="en-US" dirty="0"/>
+              <a:t>, 2024.</a:t>
+            </a:r>
+          </a:p>
+          <a:p>
+            <a:pPr>
+              <a:buNone/>
+            </a:pPr>
+            <a:br>
+              <a:rPr lang="en-US" dirty="0"/>
+            </a:br>
+            <a:endParaRPr lang="en-US" dirty="0"/>
+          </a:p>
+        </p:txBody>
+      </p:sp>
+    </p:spTree>
+    <p:extLst>
+      <p:ext uri="{BB962C8B-B14F-4D97-AF65-F5344CB8AC3E}">
+        <p14:creationId xmlns:p14="http://schemas.microsoft.com/office/powerpoint/2010/main" val="1818813885"/>
+      </p:ext>
+    </p:extLst>
   </p:cSld>
   <p:clrMapOvr>
     <a:masterClrMapping/>

</xml_diff>